<commit_message>
feat: update readme and finalise powerpoint
</commit_message>
<xml_diff>
--- a/Intro to Github workshop.pptx
+++ b/Intro to Github workshop.pptx
@@ -5,7 +5,7 @@
     <p:sldMasterId id="2147483648" r:id="rId1"/>
   </p:sldMasterIdLst>
   <p:notesMasterIdLst>
-    <p:notesMasterId r:id="rId16"/>
+    <p:notesMasterId r:id="rId10"/>
   </p:notesMasterIdLst>
   <p:sldIdLst>
     <p:sldId id="256" r:id="rId2"/>
@@ -14,14 +14,8 @@
     <p:sldId id="258" r:id="rId5"/>
     <p:sldId id="271" r:id="rId6"/>
     <p:sldId id="257" r:id="rId7"/>
-    <p:sldId id="272" r:id="rId8"/>
-    <p:sldId id="264" r:id="rId9"/>
-    <p:sldId id="266" r:id="rId10"/>
-    <p:sldId id="265" r:id="rId11"/>
-    <p:sldId id="267" r:id="rId12"/>
-    <p:sldId id="268" r:id="rId13"/>
-    <p:sldId id="269" r:id="rId14"/>
-    <p:sldId id="270" r:id="rId15"/>
+    <p:sldId id="273" r:id="rId8"/>
+    <p:sldId id="274" r:id="rId9"/>
   </p:sldIdLst>
   <p:sldSz cx="12192000" cy="6858000"/>
   <p:notesSz cx="6858000" cy="9144000"/>
@@ -131,6 +125,7 @@
 <file path=ppt/revisionInfo.xml><?xml version="1.0" encoding="utf-8"?>
 <p1510:revInfo xmlns:a="http://schemas.openxmlformats.org/drawingml/2006/main" xmlns:r="http://schemas.openxmlformats.org/officeDocument/2006/relationships" xmlns:p1510="http://schemas.microsoft.com/office/powerpoint/2015/10/main">
   <p1510:revLst>
+    <p1510:client id="{98F50609-2DD4-495C-B6E5-71E23A819DF2}" v="3" dt="2026-03-16T14:35:56.533"/>
     <p1510:client id="{C57BFA54-D39E-457E-984A-7C8C0CA81160}" v="136" dt="2026-03-16T13:23:30.635"/>
   </p1510:revLst>
 </p1510:revInfo>
@@ -141,7 +136,7 @@
   <pc:docChgLst>
     <pc:chgData name="Middleton, FS, Miss [fmiddleton@sun.ac.za]" userId="3d1ab7f5-479f-45c8-892f-75d569044a2c" providerId="ADAL" clId="{503A42E0-A9D8-410F-9C3E-B7F3C5E905A0}"/>
     <pc:docChg chg="undo custSel addSld delSld modSld sldOrd">
-      <pc:chgData name="Middleton, FS, Miss [fmiddleton@sun.ac.za]" userId="3d1ab7f5-479f-45c8-892f-75d569044a2c" providerId="ADAL" clId="{503A42E0-A9D8-410F-9C3E-B7F3C5E905A0}" dt="2026-03-16T13:52:20.984" v="3382" actId="20577"/>
+      <pc:chgData name="Middleton, FS, Miss [fmiddleton@sun.ac.za]" userId="3d1ab7f5-479f-45c8-892f-75d569044a2c" providerId="ADAL" clId="{503A42E0-A9D8-410F-9C3E-B7F3C5E905A0}" dt="2026-03-16T14:36:16.587" v="3752" actId="20577"/>
       <pc:docMkLst>
         <pc:docMk/>
       </pc:docMkLst>
@@ -761,83 +756,43 @@
           <pc:sldMk cId="3550848070" sldId="263"/>
         </pc:sldMkLst>
       </pc:sldChg>
-      <pc:sldChg chg="addSp modSp new mod">
-        <pc:chgData name="Middleton, FS, Miss [fmiddleton@sun.ac.za]" userId="3d1ab7f5-479f-45c8-892f-75d569044a2c" providerId="ADAL" clId="{503A42E0-A9D8-410F-9C3E-B7F3C5E905A0}" dt="2026-03-11T12:12:57.044" v="2102" actId="962"/>
+      <pc:sldChg chg="addSp modSp new del mod">
+        <pc:chgData name="Middleton, FS, Miss [fmiddleton@sun.ac.za]" userId="3d1ab7f5-479f-45c8-892f-75d569044a2c" providerId="ADAL" clId="{503A42E0-A9D8-410F-9C3E-B7F3C5E905A0}" dt="2026-03-16T14:35:47.577" v="3716" actId="47"/>
         <pc:sldMkLst>
           <pc:docMk/>
           <pc:sldMk cId="219079411" sldId="264"/>
         </pc:sldMkLst>
-        <pc:picChg chg="add mod">
-          <ac:chgData name="Middleton, FS, Miss [fmiddleton@sun.ac.za]" userId="3d1ab7f5-479f-45c8-892f-75d569044a2c" providerId="ADAL" clId="{503A42E0-A9D8-410F-9C3E-B7F3C5E905A0}" dt="2026-03-11T12:12:57.044" v="2102" actId="962"/>
-          <ac:picMkLst>
-            <pc:docMk/>
-            <pc:sldMk cId="219079411" sldId="264"/>
-            <ac:picMk id="3" creationId="{7322C78F-39F2-CE37-CDA9-A8B47C8853FA}"/>
-          </ac:picMkLst>
-        </pc:picChg>
       </pc:sldChg>
-      <pc:sldChg chg="addSp modSp new mod ord">
-        <pc:chgData name="Middleton, FS, Miss [fmiddleton@sun.ac.za]" userId="3d1ab7f5-479f-45c8-892f-75d569044a2c" providerId="ADAL" clId="{503A42E0-A9D8-410F-9C3E-B7F3C5E905A0}" dt="2026-03-11T12:16:40.263" v="2120"/>
+      <pc:sldChg chg="addSp modSp new del mod ord">
+        <pc:chgData name="Middleton, FS, Miss [fmiddleton@sun.ac.za]" userId="3d1ab7f5-479f-45c8-892f-75d569044a2c" providerId="ADAL" clId="{503A42E0-A9D8-410F-9C3E-B7F3C5E905A0}" dt="2026-03-16T14:35:47.577" v="3716" actId="47"/>
         <pc:sldMkLst>
           <pc:docMk/>
           <pc:sldMk cId="3027174754" sldId="265"/>
         </pc:sldMkLst>
-        <pc:picChg chg="add mod">
-          <ac:chgData name="Middleton, FS, Miss [fmiddleton@sun.ac.za]" userId="3d1ab7f5-479f-45c8-892f-75d569044a2c" providerId="ADAL" clId="{503A42E0-A9D8-410F-9C3E-B7F3C5E905A0}" dt="2026-03-11T12:14:42.178" v="2106" actId="962"/>
-          <ac:picMkLst>
-            <pc:docMk/>
-            <pc:sldMk cId="3027174754" sldId="265"/>
-            <ac:picMk id="3" creationId="{287E79D1-9FBE-020D-2ECB-6C83C788FBC3}"/>
-          </ac:picMkLst>
-        </pc:picChg>
       </pc:sldChg>
-      <pc:sldChg chg="addSp modSp new mod ord">
-        <pc:chgData name="Middleton, FS, Miss [fmiddleton@sun.ac.za]" userId="3d1ab7f5-479f-45c8-892f-75d569044a2c" providerId="ADAL" clId="{503A42E0-A9D8-410F-9C3E-B7F3C5E905A0}" dt="2026-03-11T12:15:45.195" v="2111" actId="27614"/>
+      <pc:sldChg chg="addSp modSp new del mod ord">
+        <pc:chgData name="Middleton, FS, Miss [fmiddleton@sun.ac.za]" userId="3d1ab7f5-479f-45c8-892f-75d569044a2c" providerId="ADAL" clId="{503A42E0-A9D8-410F-9C3E-B7F3C5E905A0}" dt="2026-03-16T14:35:47.577" v="3716" actId="47"/>
         <pc:sldMkLst>
           <pc:docMk/>
           <pc:sldMk cId="1802988582" sldId="266"/>
         </pc:sldMkLst>
-        <pc:picChg chg="add mod">
-          <ac:chgData name="Middleton, FS, Miss [fmiddleton@sun.ac.za]" userId="3d1ab7f5-479f-45c8-892f-75d569044a2c" providerId="ADAL" clId="{503A42E0-A9D8-410F-9C3E-B7F3C5E905A0}" dt="2026-03-11T12:15:45.195" v="2111" actId="27614"/>
-          <ac:picMkLst>
-            <pc:docMk/>
-            <pc:sldMk cId="1802988582" sldId="266"/>
-            <ac:picMk id="3" creationId="{F9DD3257-B768-22D2-B6AC-D3012B3E101B}"/>
-          </ac:picMkLst>
-        </pc:picChg>
       </pc:sldChg>
-      <pc:sldChg chg="addSp modSp new mod">
-        <pc:chgData name="Middleton, FS, Miss [fmiddleton@sun.ac.za]" userId="3d1ab7f5-479f-45c8-892f-75d569044a2c" providerId="ADAL" clId="{503A42E0-A9D8-410F-9C3E-B7F3C5E905A0}" dt="2026-03-11T12:16:37.021" v="2118" actId="27614"/>
+      <pc:sldChg chg="addSp modSp new del mod">
+        <pc:chgData name="Middleton, FS, Miss [fmiddleton@sun.ac.za]" userId="3d1ab7f5-479f-45c8-892f-75d569044a2c" providerId="ADAL" clId="{503A42E0-A9D8-410F-9C3E-B7F3C5E905A0}" dt="2026-03-16T14:35:47.577" v="3716" actId="47"/>
         <pc:sldMkLst>
           <pc:docMk/>
           <pc:sldMk cId="3546088646" sldId="267"/>
         </pc:sldMkLst>
-        <pc:picChg chg="add mod">
-          <ac:chgData name="Middleton, FS, Miss [fmiddleton@sun.ac.za]" userId="3d1ab7f5-479f-45c8-892f-75d569044a2c" providerId="ADAL" clId="{503A42E0-A9D8-410F-9C3E-B7F3C5E905A0}" dt="2026-03-11T12:16:37.021" v="2118" actId="27614"/>
-          <ac:picMkLst>
-            <pc:docMk/>
-            <pc:sldMk cId="3546088646" sldId="267"/>
-            <ac:picMk id="3" creationId="{DFAE214E-DA7C-FAB3-57C9-AD01EA739728}"/>
-          </ac:picMkLst>
-        </pc:picChg>
       </pc:sldChg>
-      <pc:sldChg chg="addSp modSp new mod">
-        <pc:chgData name="Middleton, FS, Miss [fmiddleton@sun.ac.za]" userId="3d1ab7f5-479f-45c8-892f-75d569044a2c" providerId="ADAL" clId="{503A42E0-A9D8-410F-9C3E-B7F3C5E905A0}" dt="2026-03-11T12:23:05.842" v="2125" actId="962"/>
+      <pc:sldChg chg="addSp modSp new del mod">
+        <pc:chgData name="Middleton, FS, Miss [fmiddleton@sun.ac.za]" userId="3d1ab7f5-479f-45c8-892f-75d569044a2c" providerId="ADAL" clId="{503A42E0-A9D8-410F-9C3E-B7F3C5E905A0}" dt="2026-03-16T14:35:47.577" v="3716" actId="47"/>
         <pc:sldMkLst>
           <pc:docMk/>
           <pc:sldMk cId="2699606769" sldId="268"/>
         </pc:sldMkLst>
-        <pc:picChg chg="add mod">
-          <ac:chgData name="Middleton, FS, Miss [fmiddleton@sun.ac.za]" userId="3d1ab7f5-479f-45c8-892f-75d569044a2c" providerId="ADAL" clId="{503A42E0-A9D8-410F-9C3E-B7F3C5E905A0}" dt="2026-03-11T12:23:05.842" v="2125" actId="962"/>
-          <ac:picMkLst>
-            <pc:docMk/>
-            <pc:sldMk cId="2699606769" sldId="268"/>
-            <ac:picMk id="3" creationId="{ADB8FF8B-3981-0586-E665-186A92AF1315}"/>
-          </ac:picMkLst>
-        </pc:picChg>
       </pc:sldChg>
-      <pc:sldChg chg="addSp modSp new mod">
-        <pc:chgData name="Middleton, FS, Miss [fmiddleton@sun.ac.za]" userId="3d1ab7f5-479f-45c8-892f-75d569044a2c" providerId="ADAL" clId="{503A42E0-A9D8-410F-9C3E-B7F3C5E905A0}" dt="2026-03-16T13:07:37.390" v="3156" actId="1076"/>
+      <pc:sldChg chg="addSp modSp new del mod">
+        <pc:chgData name="Middleton, FS, Miss [fmiddleton@sun.ac.za]" userId="3d1ab7f5-479f-45c8-892f-75d569044a2c" providerId="ADAL" clId="{503A42E0-A9D8-410F-9C3E-B7F3C5E905A0}" dt="2026-03-16T14:35:47.577" v="3716" actId="47"/>
         <pc:sldMkLst>
           <pc:docMk/>
           <pc:sldMk cId="3140710092" sldId="269"/>
@@ -851,20 +806,12 @@
           </ac:picMkLst>
         </pc:picChg>
       </pc:sldChg>
-      <pc:sldChg chg="addSp modSp new mod">
-        <pc:chgData name="Middleton, FS, Miss [fmiddleton@sun.ac.za]" userId="3d1ab7f5-479f-45c8-892f-75d569044a2c" providerId="ADAL" clId="{503A42E0-A9D8-410F-9C3E-B7F3C5E905A0}" dt="2026-03-11T12:29:52.277" v="2132" actId="962"/>
+      <pc:sldChg chg="addSp modSp new del mod">
+        <pc:chgData name="Middleton, FS, Miss [fmiddleton@sun.ac.za]" userId="3d1ab7f5-479f-45c8-892f-75d569044a2c" providerId="ADAL" clId="{503A42E0-A9D8-410F-9C3E-B7F3C5E905A0}" dt="2026-03-16T14:35:47.577" v="3716" actId="47"/>
         <pc:sldMkLst>
           <pc:docMk/>
           <pc:sldMk cId="3307885250" sldId="270"/>
         </pc:sldMkLst>
-        <pc:picChg chg="add mod">
-          <ac:chgData name="Middleton, FS, Miss [fmiddleton@sun.ac.za]" userId="3d1ab7f5-479f-45c8-892f-75d569044a2c" providerId="ADAL" clId="{503A42E0-A9D8-410F-9C3E-B7F3C5E905A0}" dt="2026-03-11T12:29:52.277" v="2132" actId="962"/>
-          <ac:picMkLst>
-            <pc:docMk/>
-            <pc:sldMk cId="3307885250" sldId="270"/>
-            <ac:picMk id="3" creationId="{7F2F9BE8-9DFA-BA59-61A6-D7423A148917}"/>
-          </ac:picMkLst>
-        </pc:picChg>
       </pc:sldChg>
       <pc:sldChg chg="addSp delSp modSp add mod delAnim modAnim">
         <pc:chgData name="Middleton, FS, Miss [fmiddleton@sun.ac.za]" userId="3d1ab7f5-479f-45c8-892f-75d569044a2c" providerId="ADAL" clId="{503A42E0-A9D8-410F-9C3E-B7F3C5E905A0}" dt="2026-03-16T13:23:30.635" v="3278"/>
@@ -1145,8 +1092,8 @@
           </ac:picMkLst>
         </pc:picChg>
       </pc:sldChg>
-      <pc:sldChg chg="addSp modSp new mod">
-        <pc:chgData name="Middleton, FS, Miss [fmiddleton@sun.ac.za]" userId="3d1ab7f5-479f-45c8-892f-75d569044a2c" providerId="ADAL" clId="{503A42E0-A9D8-410F-9C3E-B7F3C5E905A0}" dt="2026-03-16T13:40:12.356" v="3291" actId="962"/>
+      <pc:sldChg chg="addSp modSp new del mod">
+        <pc:chgData name="Middleton, FS, Miss [fmiddleton@sun.ac.za]" userId="3d1ab7f5-479f-45c8-892f-75d569044a2c" providerId="ADAL" clId="{503A42E0-A9D8-410F-9C3E-B7F3C5E905A0}" dt="2026-03-16T14:35:47.577" v="3716" actId="47"/>
         <pc:sldMkLst>
           <pc:docMk/>
           <pc:sldMk cId="3060776340" sldId="272"/>
@@ -1159,6 +1106,100 @@
             <ac:picMk id="5" creationId="{59CAEEB0-6481-EAD8-1EEA-E7D9ABC1F2A8}"/>
           </ac:picMkLst>
         </pc:picChg>
+      </pc:sldChg>
+      <pc:sldChg chg="modSp add mod">
+        <pc:chgData name="Middleton, FS, Miss [fmiddleton@sun.ac.za]" userId="3d1ab7f5-479f-45c8-892f-75d569044a2c" providerId="ADAL" clId="{503A42E0-A9D8-410F-9C3E-B7F3C5E905A0}" dt="2026-03-16T14:35:39.547" v="3715" actId="20577"/>
+        <pc:sldMkLst>
+          <pc:docMk/>
+          <pc:sldMk cId="2970140492" sldId="273"/>
+        </pc:sldMkLst>
+        <pc:spChg chg="mod">
+          <ac:chgData name="Middleton, FS, Miss [fmiddleton@sun.ac.za]" userId="3d1ab7f5-479f-45c8-892f-75d569044a2c" providerId="ADAL" clId="{503A42E0-A9D8-410F-9C3E-B7F3C5E905A0}" dt="2026-03-16T14:31:05.967" v="3410" actId="20577"/>
+          <ac:spMkLst>
+            <pc:docMk/>
+            <pc:sldMk cId="2970140492" sldId="273"/>
+            <ac:spMk id="2" creationId="{2C3B7EEF-979D-5DA4-4BF5-55803C74C76D}"/>
+          </ac:spMkLst>
+        </pc:spChg>
+        <pc:spChg chg="mod">
+          <ac:chgData name="Middleton, FS, Miss [fmiddleton@sun.ac.za]" userId="3d1ab7f5-479f-45c8-892f-75d569044a2c" providerId="ADAL" clId="{503A42E0-A9D8-410F-9C3E-B7F3C5E905A0}" dt="2026-03-16T14:35:39.547" v="3715" actId="20577"/>
+          <ac:spMkLst>
+            <pc:docMk/>
+            <pc:sldMk cId="2970140492" sldId="273"/>
+            <ac:spMk id="3" creationId="{127EC1C3-EAB9-5A3A-163B-949E3A5F3134}"/>
+          </ac:spMkLst>
+        </pc:spChg>
+      </pc:sldChg>
+      <pc:sldChg chg="addSp delSp modSp add mod ord setBg addAnim delDesignElem">
+        <pc:chgData name="Middleton, FS, Miss [fmiddleton@sun.ac.za]" userId="3d1ab7f5-479f-45c8-892f-75d569044a2c" providerId="ADAL" clId="{503A42E0-A9D8-410F-9C3E-B7F3C5E905A0}" dt="2026-03-16T14:36:16.587" v="3752" actId="20577"/>
+        <pc:sldMkLst>
+          <pc:docMk/>
+          <pc:sldMk cId="3793282809" sldId="274"/>
+        </pc:sldMkLst>
+        <pc:spChg chg="mod">
+          <ac:chgData name="Middleton, FS, Miss [fmiddleton@sun.ac.za]" userId="3d1ab7f5-479f-45c8-892f-75d569044a2c" providerId="ADAL" clId="{503A42E0-A9D8-410F-9C3E-B7F3C5E905A0}" dt="2026-03-16T14:36:13.455" v="3750" actId="26606"/>
+          <ac:spMkLst>
+            <pc:docMk/>
+            <pc:sldMk cId="3793282809" sldId="274"/>
+            <ac:spMk id="2" creationId="{14A1F042-E4D7-BF49-E82F-204BC69BC57C}"/>
+          </ac:spMkLst>
+        </pc:spChg>
+        <pc:spChg chg="add mod">
+          <ac:chgData name="Middleton, FS, Miss [fmiddleton@sun.ac.za]" userId="3d1ab7f5-479f-45c8-892f-75d569044a2c" providerId="ADAL" clId="{503A42E0-A9D8-410F-9C3E-B7F3C5E905A0}" dt="2026-03-16T14:36:16.587" v="3752" actId="20577"/>
+          <ac:spMkLst>
+            <pc:docMk/>
+            <pc:sldMk cId="3793282809" sldId="274"/>
+            <ac:spMk id="3" creationId="{F1DA2FFC-6FF6-A48A-4924-76043C6B835A}"/>
+          </ac:spMkLst>
+        </pc:spChg>
+        <pc:spChg chg="add">
+          <ac:chgData name="Middleton, FS, Miss [fmiddleton@sun.ac.za]" userId="3d1ab7f5-479f-45c8-892f-75d569044a2c" providerId="ADAL" clId="{503A42E0-A9D8-410F-9C3E-B7F3C5E905A0}" dt="2026-03-16T14:36:13.455" v="3750" actId="26606"/>
+          <ac:spMkLst>
+            <pc:docMk/>
+            <pc:sldMk cId="3793282809" sldId="274"/>
+            <ac:spMk id="8" creationId="{289ED1AA-8684-4D37-B208-8777E1A7780D}"/>
+          </ac:spMkLst>
+        </pc:spChg>
+        <pc:spChg chg="add">
+          <ac:chgData name="Middleton, FS, Miss [fmiddleton@sun.ac.za]" userId="3d1ab7f5-479f-45c8-892f-75d569044a2c" providerId="ADAL" clId="{503A42E0-A9D8-410F-9C3E-B7F3C5E905A0}" dt="2026-03-16T14:36:13.455" v="3750" actId="26606"/>
+          <ac:spMkLst>
+            <pc:docMk/>
+            <pc:sldMk cId="3793282809" sldId="274"/>
+            <ac:spMk id="10" creationId="{4180E01B-B1F4-437C-807D-1C930718EE64}"/>
+          </ac:spMkLst>
+        </pc:spChg>
+        <pc:spChg chg="add">
+          <ac:chgData name="Middleton, FS, Miss [fmiddleton@sun.ac.za]" userId="3d1ab7f5-479f-45c8-892f-75d569044a2c" providerId="ADAL" clId="{503A42E0-A9D8-410F-9C3E-B7F3C5E905A0}" dt="2026-03-16T14:36:13.455" v="3750" actId="26606"/>
+          <ac:spMkLst>
+            <pc:docMk/>
+            <pc:sldMk cId="3793282809" sldId="274"/>
+            <ac:spMk id="12" creationId="{41F77738-2AF0-4750-A0C7-F97C2C17590E}"/>
+          </ac:spMkLst>
+        </pc:spChg>
+        <pc:spChg chg="del">
+          <ac:chgData name="Middleton, FS, Miss [fmiddleton@sun.ac.za]" userId="3d1ab7f5-479f-45c8-892f-75d569044a2c" providerId="ADAL" clId="{503A42E0-A9D8-410F-9C3E-B7F3C5E905A0}" dt="2026-03-16T14:35:50.462" v="3718"/>
+          <ac:spMkLst>
+            <pc:docMk/>
+            <pc:sldMk cId="3793282809" sldId="274"/>
+            <ac:spMk id="213" creationId="{2F74FB65-6CCC-6C0C-963C-D17065F04DF6}"/>
+          </ac:spMkLst>
+        </pc:spChg>
+        <pc:spChg chg="del">
+          <ac:chgData name="Middleton, FS, Miss [fmiddleton@sun.ac.za]" userId="3d1ab7f5-479f-45c8-892f-75d569044a2c" providerId="ADAL" clId="{503A42E0-A9D8-410F-9C3E-B7F3C5E905A0}" dt="2026-03-16T14:35:50.462" v="3718"/>
+          <ac:spMkLst>
+            <pc:docMk/>
+            <pc:sldMk cId="3793282809" sldId="274"/>
+            <ac:spMk id="215" creationId="{BD4BB25D-D8BE-5754-CFA1-6B72C49A455B}"/>
+          </ac:spMkLst>
+        </pc:spChg>
+        <pc:spChg chg="del">
+          <ac:chgData name="Middleton, FS, Miss [fmiddleton@sun.ac.za]" userId="3d1ab7f5-479f-45c8-892f-75d569044a2c" providerId="ADAL" clId="{503A42E0-A9D8-410F-9C3E-B7F3C5E905A0}" dt="2026-03-16T14:35:50.462" v="3718"/>
+          <ac:spMkLst>
+            <pc:docMk/>
+            <pc:sldMk cId="3793282809" sldId="274"/>
+            <ac:spMk id="217" creationId="{41591452-31D2-1275-2ECD-7AF8B98FEAB8}"/>
+          </ac:spMkLst>
+        </pc:spChg>
       </pc:sldChg>
     </pc:docChg>
   </pc:docChgLst>
@@ -5673,306 +5714,6 @@
     <p:extLst>
       <p:ext uri="{BB962C8B-B14F-4D97-AF65-F5344CB8AC3E}">
         <p14:creationId xmlns:p14="http://schemas.microsoft.com/office/powerpoint/2010/main" val="1412634538"/>
-      </p:ext>
-    </p:extLst>
-  </p:cSld>
-  <p:clrMapOvr>
-    <a:masterClrMapping/>
-  </p:clrMapOvr>
-</p:sld>
-</file>
-
-<file path=ppt/slides/slide10.xml><?xml version="1.0" encoding="utf-8"?>
-<p:sld xmlns:a="http://schemas.openxmlformats.org/drawingml/2006/main" xmlns:r="http://schemas.openxmlformats.org/officeDocument/2006/relationships" xmlns:p="http://schemas.openxmlformats.org/presentationml/2006/main">
-  <p:cSld>
-    <p:spTree>
-      <p:nvGrpSpPr>
-        <p:cNvPr id="1" name=""/>
-        <p:cNvGrpSpPr/>
-        <p:nvPr/>
-      </p:nvGrpSpPr>
-      <p:grpSpPr>
-        <a:xfrm>
-          <a:off x="0" y="0"/>
-          <a:ext cx="0" cy="0"/>
-          <a:chOff x="0" y="0"/>
-          <a:chExt cx="0" cy="0"/>
-        </a:xfrm>
-      </p:grpSpPr>
-      <p:pic>
-        <p:nvPicPr>
-          <p:cNvPr id="3" name="Picture 2" descr="The image appears to be a screenshot or visual representation of a permissions or access control panel within an application or software platform, specifically a section dedicated to managing collaborators and teams for a private repository.&#10;&#10;AI-generated content may be incorrect.">
-            <a:extLst>
-              <a:ext uri="{FF2B5EF4-FFF2-40B4-BE49-F238E27FC236}">
-                <a16:creationId xmlns:a16="http://schemas.microsoft.com/office/drawing/2014/main" id="{287E79D1-9FBE-020D-2ECB-6C83C788FBC3}"/>
-              </a:ext>
-            </a:extLst>
-          </p:cNvPr>
-          <p:cNvPicPr>
-            <a:picLocks noChangeAspect="1"/>
-          </p:cNvPicPr>
-          <p:nvPr/>
-        </p:nvPicPr>
-        <p:blipFill>
-          <a:blip r:embed="rId2"/>
-          <a:stretch>
-            <a:fillRect/>
-          </a:stretch>
-        </p:blipFill>
-        <p:spPr>
-          <a:xfrm>
-            <a:off x="380202" y="428206"/>
-            <a:ext cx="11431595" cy="6001588"/>
-          </a:xfrm>
-          <a:prstGeom prst="rect">
-            <a:avLst/>
-          </a:prstGeom>
-        </p:spPr>
-      </p:pic>
-    </p:spTree>
-    <p:extLst>
-      <p:ext uri="{BB962C8B-B14F-4D97-AF65-F5344CB8AC3E}">
-        <p14:creationId xmlns:p14="http://schemas.microsoft.com/office/powerpoint/2010/main" val="3027174754"/>
-      </p:ext>
-    </p:extLst>
-  </p:cSld>
-  <p:clrMapOvr>
-    <a:masterClrMapping/>
-  </p:clrMapOvr>
-</p:sld>
-</file>
-
-<file path=ppt/slides/slide11.xml><?xml version="1.0" encoding="utf-8"?>
-<p:sld xmlns:a="http://schemas.openxmlformats.org/drawingml/2006/main" xmlns:r="http://schemas.openxmlformats.org/officeDocument/2006/relationships" xmlns:p="http://schemas.openxmlformats.org/presentationml/2006/main">
-  <p:cSld>
-    <p:spTree>
-      <p:nvGrpSpPr>
-        <p:cNvPr id="1" name=""/>
-        <p:cNvGrpSpPr/>
-        <p:nvPr/>
-      </p:nvGrpSpPr>
-      <p:grpSpPr>
-        <a:xfrm>
-          <a:off x="0" y="0"/>
-          <a:ext cx="0" cy="0"/>
-          <a:chOff x="0" y="0"/>
-          <a:chExt cx="0" cy="0"/>
-        </a:xfrm>
-      </p:grpSpPr>
-      <p:pic>
-        <p:nvPicPr>
-          <p:cNvPr id="3" name="Picture 2" descr="hello-ml-research-group&#10;&#10;AI-generated content may be incorrect.">
-            <a:extLst>
-              <a:ext uri="{FF2B5EF4-FFF2-40B4-BE49-F238E27FC236}">
-                <a16:creationId xmlns:a16="http://schemas.microsoft.com/office/drawing/2014/main" id="{DFAE214E-DA7C-FAB3-57C9-AD01EA739728}"/>
-              </a:ext>
-            </a:extLst>
-          </p:cNvPr>
-          <p:cNvPicPr>
-            <a:picLocks noChangeAspect="1"/>
-          </p:cNvPicPr>
-          <p:nvPr/>
-        </p:nvPicPr>
-        <p:blipFill>
-          <a:blip r:embed="rId2"/>
-          <a:stretch>
-            <a:fillRect/>
-          </a:stretch>
-        </p:blipFill>
-        <p:spPr>
-          <a:xfrm>
-            <a:off x="1418572" y="890233"/>
-            <a:ext cx="9354856" cy="5077534"/>
-          </a:xfrm>
-          <a:prstGeom prst="rect">
-            <a:avLst/>
-          </a:prstGeom>
-        </p:spPr>
-      </p:pic>
-    </p:spTree>
-    <p:extLst>
-      <p:ext uri="{BB962C8B-B14F-4D97-AF65-F5344CB8AC3E}">
-        <p14:creationId xmlns:p14="http://schemas.microsoft.com/office/powerpoint/2010/main" val="3546088646"/>
-      </p:ext>
-    </p:extLst>
-  </p:cSld>
-  <p:clrMapOvr>
-    <a:masterClrMapping/>
-  </p:clrMapOvr>
-</p:sld>
-</file>
-
-<file path=ppt/slides/slide12.xml><?xml version="1.0" encoding="utf-8"?>
-<p:sld xmlns:a="http://schemas.openxmlformats.org/drawingml/2006/main" xmlns:r="http://schemas.openxmlformats.org/officeDocument/2006/relationships" xmlns:p="http://schemas.openxmlformats.org/presentationml/2006/main">
-  <p:cSld>
-    <p:spTree>
-      <p:nvGrpSpPr>
-        <p:cNvPr id="1" name=""/>
-        <p:cNvGrpSpPr/>
-        <p:nvPr/>
-      </p:nvGrpSpPr>
-      <p:grpSpPr>
-        <a:xfrm>
-          <a:off x="0" y="0"/>
-          <a:ext cx="0" cy="0"/>
-          <a:chOff x="0" y="0"/>
-          <a:chExt cx="0" cy="0"/>
-        </a:xfrm>
-      </p:grpSpPr>
-      <p:pic>
-        <p:nvPicPr>
-          <p:cNvPr id="3" name="Picture 2" descr="Clone Repository&#10;&#10;AI-generated content may be incorrect.">
-            <a:extLst>
-              <a:ext uri="{FF2B5EF4-FFF2-40B4-BE49-F238E27FC236}">
-                <a16:creationId xmlns:a16="http://schemas.microsoft.com/office/drawing/2014/main" id="{ADB8FF8B-3981-0586-E665-186A92AF1315}"/>
-              </a:ext>
-            </a:extLst>
-          </p:cNvPr>
-          <p:cNvPicPr>
-            <a:picLocks noChangeAspect="1"/>
-          </p:cNvPicPr>
-          <p:nvPr/>
-        </p:nvPicPr>
-        <p:blipFill>
-          <a:blip r:embed="rId2"/>
-          <a:stretch>
-            <a:fillRect/>
-          </a:stretch>
-        </p:blipFill>
-        <p:spPr>
-          <a:xfrm>
-            <a:off x="4354282" y="988803"/>
-            <a:ext cx="3305636" cy="3000794"/>
-          </a:xfrm>
-          <a:prstGeom prst="rect">
-            <a:avLst/>
-          </a:prstGeom>
-        </p:spPr>
-      </p:pic>
-    </p:spTree>
-    <p:extLst>
-      <p:ext uri="{BB962C8B-B14F-4D97-AF65-F5344CB8AC3E}">
-        <p14:creationId xmlns:p14="http://schemas.microsoft.com/office/powerpoint/2010/main" val="2699606769"/>
-      </p:ext>
-    </p:extLst>
-  </p:cSld>
-  <p:clrMapOvr>
-    <a:masterClrMapping/>
-  </p:clrMapOvr>
-</p:sld>
-</file>
-
-<file path=ppt/slides/slide13.xml><?xml version="1.0" encoding="utf-8"?>
-<p:sld xmlns:a="http://schemas.openxmlformats.org/drawingml/2006/main" xmlns:r="http://schemas.openxmlformats.org/officeDocument/2006/relationships" xmlns:p="http://schemas.openxmlformats.org/presentationml/2006/main">
-  <p:cSld>
-    <p:spTree>
-      <p:nvGrpSpPr>
-        <p:cNvPr id="1" name=""/>
-        <p:cNvGrpSpPr/>
-        <p:nvPr/>
-      </p:nvGrpSpPr>
-      <p:grpSpPr>
-        <a:xfrm>
-          <a:off x="0" y="0"/>
-          <a:ext cx="0" cy="0"/>
-          <a:chOff x="0" y="0"/>
-          <a:chExt cx="0" cy="0"/>
-        </a:xfrm>
-      </p:grpSpPr>
-      <p:pic>
-        <p:nvPicPr>
-          <p:cNvPr id="3" name="Picture 2" descr="The image shows a screen displaying a Git command prompt, with the user currently working on the 'add_tutorial' branch of a repository, ready to add changes to the README.md file.&#10;&#10;AI-generated content may be incorrect.">
-            <a:extLst>
-              <a:ext uri="{FF2B5EF4-FFF2-40B4-BE49-F238E27FC236}">
-                <a16:creationId xmlns:a16="http://schemas.microsoft.com/office/drawing/2014/main" id="{F643FC20-A99D-FB4D-594A-9F2866059BB2}"/>
-              </a:ext>
-            </a:extLst>
-          </p:cNvPr>
-          <p:cNvPicPr>
-            <a:picLocks noChangeAspect="1"/>
-          </p:cNvPicPr>
-          <p:nvPr/>
-        </p:nvPicPr>
-        <p:blipFill>
-          <a:blip r:embed="rId2"/>
-          <a:stretch>
-            <a:fillRect/>
-          </a:stretch>
-        </p:blipFill>
-        <p:spPr>
-          <a:xfrm>
-            <a:off x="1602392" y="0"/>
-            <a:ext cx="8987215" cy="6300190"/>
-          </a:xfrm>
-          <a:prstGeom prst="rect">
-            <a:avLst/>
-          </a:prstGeom>
-        </p:spPr>
-      </p:pic>
-    </p:spTree>
-    <p:extLst>
-      <p:ext uri="{BB962C8B-B14F-4D97-AF65-F5344CB8AC3E}">
-        <p14:creationId xmlns:p14="http://schemas.microsoft.com/office/powerpoint/2010/main" val="3140710092"/>
-      </p:ext>
-    </p:extLst>
-  </p:cSld>
-  <p:clrMapOvr>
-    <a:masterClrMapping/>
-  </p:clrMapOvr>
-</p:sld>
-</file>
-
-<file path=ppt/slides/slide14.xml><?xml version="1.0" encoding="utf-8"?>
-<p:sld xmlns:a="http://schemas.openxmlformats.org/drawingml/2006/main" xmlns:r="http://schemas.openxmlformats.org/officeDocument/2006/relationships" xmlns:p="http://schemas.openxmlformats.org/presentationml/2006/main">
-  <p:cSld>
-    <p:spTree>
-      <p:nvGrpSpPr>
-        <p:cNvPr id="1" name=""/>
-        <p:cNvGrpSpPr/>
-        <p:nvPr/>
-      </p:nvGrpSpPr>
-      <p:grpSpPr>
-        <a:xfrm>
-          <a:off x="0" y="0"/>
-          <a:ext cx="0" cy="0"/>
-          <a:chOff x="0" y="0"/>
-          <a:chExt cx="0" cy="0"/>
-        </a:xfrm>
-      </p:grpSpPr>
-      <p:pic>
-        <p:nvPicPr>
-          <p:cNvPr id="3" name="Picture 2" descr="The image shows a software interface with a list of branches, including an option to checkout a detached branch, and it contains some text referencing a tutorial and branch identifiers.&#10;&#10;AI-generated content may be incorrect.">
-            <a:extLst>
-              <a:ext uri="{FF2B5EF4-FFF2-40B4-BE49-F238E27FC236}">
-                <a16:creationId xmlns:a16="http://schemas.microsoft.com/office/drawing/2014/main" id="{7F2F9BE8-9DFA-BA59-61A6-D7423A148917}"/>
-              </a:ext>
-            </a:extLst>
-          </p:cNvPr>
-          <p:cNvPicPr>
-            <a:picLocks noChangeAspect="1"/>
-          </p:cNvPicPr>
-          <p:nvPr/>
-        </p:nvPicPr>
-        <p:blipFill>
-          <a:blip r:embed="rId2"/>
-          <a:stretch>
-            <a:fillRect/>
-          </a:stretch>
-        </p:blipFill>
-        <p:spPr>
-          <a:xfrm>
-            <a:off x="3261917" y="2600209"/>
-            <a:ext cx="5668166" cy="1657581"/>
-          </a:xfrm>
-          <a:prstGeom prst="rect">
-            <a:avLst/>
-          </a:prstGeom>
-        </p:spPr>
-      </p:pic>
-    </p:spTree>
-    <p:extLst>
-      <p:ext uri="{BB962C8B-B14F-4D97-AF65-F5344CB8AC3E}">
-        <p14:creationId xmlns:p14="http://schemas.microsoft.com/office/powerpoint/2010/main" val="3307885250"/>
       </p:ext>
     </p:extLst>
   </p:cSld>
@@ -9505,7 +9246,13 @@
   <p:cSld>
     <p:spTree>
       <p:nvGrpSpPr>
-        <p:cNvPr id="1" name=""/>
+        <p:cNvPr id="1" name="">
+          <a:extLst>
+            <a:ext uri="{FF2B5EF4-FFF2-40B4-BE49-F238E27FC236}">
+              <a16:creationId xmlns:a16="http://schemas.microsoft.com/office/drawing/2014/main" id="{328A664C-7F7A-9044-0D6A-FD0E90F61E0F}"/>
+            </a:ext>
+          </a:extLst>
+        </p:cNvPr>
         <p:cNvGrpSpPr/>
         <p:nvPr/>
       </p:nvGrpSpPr>
@@ -9522,7 +9269,7 @@
           <p:cNvPr id="2" name="Title 1">
             <a:extLst>
               <a:ext uri="{FF2B5EF4-FFF2-40B4-BE49-F238E27FC236}">
-                <a16:creationId xmlns:a16="http://schemas.microsoft.com/office/drawing/2014/main" id="{F8923262-3000-5D22-31D3-526A3FBCCB16}"/>
+                <a16:creationId xmlns:a16="http://schemas.microsoft.com/office/drawing/2014/main" id="{2C3B7EEF-979D-5DA4-4BF5-55803C74C76D}"/>
               </a:ext>
             </a:extLst>
           </p:cNvPr>
@@ -9538,7 +9285,11 @@
           <a:bodyPr/>
           <a:lstStyle/>
           <a:p>
-            <a:endParaRPr lang="en-ZA"/>
+            <a:r>
+              <a:rPr lang="en-US" dirty="0"/>
+              <a:t>What we will do in the workshop	</a:t>
+            </a:r>
+            <a:endParaRPr lang="en-ZA" dirty="0"/>
           </a:p>
         </p:txBody>
       </p:sp>
@@ -9547,7 +9298,7 @@
           <p:cNvPr id="3" name="Content Placeholder 2">
             <a:extLst>
               <a:ext uri="{FF2B5EF4-FFF2-40B4-BE49-F238E27FC236}">
-                <a16:creationId xmlns:a16="http://schemas.microsoft.com/office/drawing/2014/main" id="{74477ADC-E4A1-5D9B-59B9-D79C1FE6EFD3}"/>
+                <a16:creationId xmlns:a16="http://schemas.microsoft.com/office/drawing/2014/main" id="{127EC1C3-EAB9-5A3A-163B-949E3A5F3134}"/>
               </a:ext>
             </a:extLst>
           </p:cNvPr>
@@ -9563,44 +9314,68 @@
           <a:bodyPr/>
           <a:lstStyle/>
           <a:p>
-            <a:endParaRPr lang="en-ZA"/>
+            <a:r>
+              <a:rPr lang="en-US" dirty="0"/>
+              <a:t>Clone a repo and open it in </a:t>
+            </a:r>
+            <a:r>
+              <a:rPr lang="en-US" dirty="0" err="1"/>
+              <a:t>VSCode</a:t>
+            </a:r>
+            <a:endParaRPr lang="en-US" dirty="0"/>
+          </a:p>
+          <a:p>
+            <a:r>
+              <a:rPr lang="en-US" dirty="0"/>
+              <a:t>Make a branch off main</a:t>
+            </a:r>
+          </a:p>
+          <a:p>
+            <a:r>
+              <a:rPr lang="en-US" dirty="0">
+                <a:sym typeface="Wingdings" panose="05000000000000000000" pitchFamily="2" charset="2"/>
+              </a:rPr>
+              <a:t>Make some change on the repo and commit it to this branch</a:t>
+            </a:r>
+          </a:p>
+          <a:p>
+            <a:r>
+              <a:rPr lang="en-US" dirty="0">
+                <a:sym typeface="Wingdings" panose="05000000000000000000" pitchFamily="2" charset="2"/>
+              </a:rPr>
+              <a:t>Open a PR and get a colleague to review it </a:t>
+            </a:r>
+          </a:p>
+          <a:p>
+            <a:r>
+              <a:rPr lang="en-US" dirty="0">
+                <a:sym typeface="Wingdings" panose="05000000000000000000" pitchFamily="2" charset="2"/>
+              </a:rPr>
+              <a:t>Merge the PR </a:t>
+            </a:r>
+          </a:p>
+          <a:p>
+            <a:r>
+              <a:rPr lang="en-US" dirty="0">
+                <a:sym typeface="Wingdings" panose="05000000000000000000" pitchFamily="2" charset="2"/>
+              </a:rPr>
+              <a:t>Look at some more resources on the fun stuff involved in GitHub</a:t>
+            </a:r>
+          </a:p>
+          <a:p>
+            <a:endParaRPr lang="en-US" dirty="0">
+              <a:sym typeface="Wingdings" panose="05000000000000000000" pitchFamily="2" charset="2"/>
+            </a:endParaRPr>
+          </a:p>
+          <a:p>
+            <a:endParaRPr lang="en-ZA" dirty="0"/>
           </a:p>
         </p:txBody>
       </p:sp>
-      <p:pic>
-        <p:nvPicPr>
-          <p:cNvPr id="5" name="Picture 4" descr="The image displays a Windows PowerShell terminal session, where the user is navigating through a Git repository directory, and the interface prompts the user to decide whether to trust the repository's contents or to proceed in a restricted mode.&#10;&#10;AI-generated content may be incorrect.">
-            <a:extLst>
-              <a:ext uri="{FF2B5EF4-FFF2-40B4-BE49-F238E27FC236}">
-                <a16:creationId xmlns:a16="http://schemas.microsoft.com/office/drawing/2014/main" id="{59CAEEB0-6481-EAD8-1EEA-E7D9ABC1F2A8}"/>
-              </a:ext>
-            </a:extLst>
-          </p:cNvPr>
-          <p:cNvPicPr>
-            <a:picLocks noChangeAspect="1"/>
-          </p:cNvPicPr>
-          <p:nvPr/>
-        </p:nvPicPr>
-        <p:blipFill>
-          <a:blip r:embed="rId2"/>
-          <a:stretch>
-            <a:fillRect/>
-          </a:stretch>
-        </p:blipFill>
-        <p:spPr>
-          <a:xfrm>
-            <a:off x="0" y="451795"/>
-            <a:ext cx="12192000" cy="5954410"/>
-          </a:xfrm>
-          <a:prstGeom prst="rect">
-            <a:avLst/>
-          </a:prstGeom>
-        </p:spPr>
-      </p:pic>
     </p:spTree>
     <p:extLst>
       <p:ext uri="{BB962C8B-B14F-4D97-AF65-F5344CB8AC3E}">
-        <p14:creationId xmlns:p14="http://schemas.microsoft.com/office/powerpoint/2010/main" val="3060776340"/>
+        <p14:creationId xmlns:p14="http://schemas.microsoft.com/office/powerpoint/2010/main" val="2970140492"/>
       </p:ext>
     </p:extLst>
   </p:cSld>
@@ -9613,9 +9388,23 @@
 <file path=ppt/slides/slide8.xml><?xml version="1.0" encoding="utf-8"?>
 <p:sld xmlns:a="http://schemas.openxmlformats.org/drawingml/2006/main" xmlns:r="http://schemas.openxmlformats.org/officeDocument/2006/relationships" xmlns:p="http://schemas.openxmlformats.org/presentationml/2006/main">
   <p:cSld>
+    <p:bg>
+      <p:bgPr>
+        <a:solidFill>
+          <a:schemeClr val="bg1"/>
+        </a:solidFill>
+        <a:effectLst/>
+      </p:bgPr>
+    </p:bg>
     <p:spTree>
       <p:nvGrpSpPr>
-        <p:cNvPr id="1" name=""/>
+        <p:cNvPr id="1" name="">
+          <a:extLst>
+            <a:ext uri="{FF2B5EF4-FFF2-40B4-BE49-F238E27FC236}">
+              <a16:creationId xmlns:a16="http://schemas.microsoft.com/office/drawing/2014/main" id="{2CA50EF1-949D-D7C1-0540-3E0152F41E6A}"/>
+            </a:ext>
+          </a:extLst>
+        </p:cNvPr>
         <p:cNvGrpSpPr/>
         <p:nvPr/>
       </p:nvGrpSpPr>
@@ -9627,106 +9416,1084 @@
           <a:chExt cx="0" cy="0"/>
         </a:xfrm>
       </p:grpSpPr>
-      <p:pic>
-        <p:nvPicPr>
-          <p:cNvPr id="3" name="Picture 2" descr="The image is a screenshot of a GitHub repository creation page with fields for repository details such as name, visibility, README, .gitignore, and license.&#10;&#10;AI-generated content may be incorrect.">
+      <p:sp useBgFill="1">
+        <p:nvSpPr>
+          <p:cNvPr id="8" name="Rectangle 7">
             <a:extLst>
               <a:ext uri="{FF2B5EF4-FFF2-40B4-BE49-F238E27FC236}">
-                <a16:creationId xmlns:a16="http://schemas.microsoft.com/office/drawing/2014/main" id="{7322C78F-39F2-CE37-CDA9-A8B47C8853FA}"/>
+                <a16:creationId xmlns:a16="http://schemas.microsoft.com/office/drawing/2014/main" id="{289ED1AA-8684-4D37-B208-8777E1A7780D}"/>
+              </a:ext>
+              <a:ext uri="{C183D7F6-B498-43B3-948B-1728B52AA6E4}">
+                <adec:decorative xmlns:adec="http://schemas.microsoft.com/office/drawing/2017/decorative" val="1"/>
               </a:ext>
             </a:extLst>
           </p:cNvPr>
-          <p:cNvPicPr>
-            <a:picLocks noChangeAspect="1"/>
-          </p:cNvPicPr>
-          <p:nvPr/>
-        </p:nvPicPr>
-        <p:blipFill>
-          <a:blip r:embed="rId2"/>
-          <a:stretch>
-            <a:fillRect/>
-          </a:stretch>
-        </p:blipFill>
+          <p:cNvSpPr>
+            <a:spLocks noGrp="1" noRot="1" noChangeAspect="1" noMove="1" noResize="1" noEditPoints="1" noAdjustHandles="1" noChangeArrowheads="1" noChangeShapeType="1" noTextEdit="1"/>
+          </p:cNvSpPr>
+          <p:nvPr>
+            <p:extLst>
+              <p:ext uri="{386F3935-93C4-4BCD-93E2-E3B085C9AB24}">
+                <p16:designElem xmlns:p16="http://schemas.microsoft.com/office/powerpoint/2015/main" val="1"/>
+              </p:ext>
+            </p:extLst>
+          </p:nvPr>
+        </p:nvSpPr>
         <p:spPr>
           <a:xfrm>
-            <a:off x="1257300" y="316206"/>
-            <a:ext cx="10439400" cy="6226762"/>
+            <a:off x="0" y="0"/>
+            <a:ext cx="12188952" cy="6858000"/>
+          </a:xfrm>
+          <a:prstGeom prst="rect">
+            <a:avLst/>
+          </a:prstGeom>
+          <a:ln>
+            <a:noFill/>
+          </a:ln>
+        </p:spPr>
+        <p:style>
+          <a:lnRef idx="2">
+            <a:schemeClr val="accent1">
+              <a:shade val="50000"/>
+            </a:schemeClr>
+          </a:lnRef>
+          <a:fillRef idx="1">
+            <a:schemeClr val="accent1"/>
+          </a:fillRef>
+          <a:effectRef idx="0">
+            <a:schemeClr val="accent1"/>
+          </a:effectRef>
+          <a:fontRef idx="minor">
+            <a:schemeClr val="lt1"/>
+          </a:fontRef>
+        </p:style>
+        <p:txBody>
+          <a:bodyPr rtlCol="0" anchor="ctr"/>
+          <a:lstStyle/>
+          <a:p>
+            <a:pPr algn="ctr"/>
+            <a:endParaRPr lang="en-US"/>
+          </a:p>
+        </p:txBody>
+      </p:sp>
+      <p:sp>
+        <p:nvSpPr>
+          <p:cNvPr id="10" name="Graphic 33">
+            <a:extLst>
+              <a:ext uri="{FF2B5EF4-FFF2-40B4-BE49-F238E27FC236}">
+                <a16:creationId xmlns:a16="http://schemas.microsoft.com/office/drawing/2014/main" id="{4180E01B-B1F4-437C-807D-1C930718EE64}"/>
+              </a:ext>
+              <a:ext uri="{C183D7F6-B498-43B3-948B-1728B52AA6E4}">
+                <adec:decorative xmlns:adec="http://schemas.microsoft.com/office/drawing/2017/decorative" val="1"/>
+              </a:ext>
+            </a:extLst>
+          </p:cNvPr>
+          <p:cNvSpPr>
+            <a:spLocks noGrp="1" noRot="1" noChangeAspect="1" noMove="1" noResize="1" noEditPoints="1" noAdjustHandles="1" noChangeArrowheads="1" noChangeShapeType="1" noTextEdit="1"/>
+          </p:cNvSpPr>
+          <p:nvPr>
+            <p:extLst>
+              <p:ext uri="{386F3935-93C4-4BCD-93E2-E3B085C9AB24}">
+                <p16:designElem xmlns:p16="http://schemas.microsoft.com/office/powerpoint/2015/main" val="1"/>
+              </p:ext>
+            </p:extLst>
+          </p:nvPr>
+        </p:nvSpPr>
+        <p:spPr>
+          <a:xfrm>
+            <a:off x="1310784" y="0"/>
+            <a:ext cx="9570431" cy="6858000"/>
+          </a:xfrm>
+          <a:custGeom>
+            <a:avLst/>
+            <a:gdLst>
+              <a:gd name="connsiteX0" fmla="*/ 7178288 w 7187261"/>
+              <a:gd name="connsiteY0" fmla="*/ 2604802 h 5150263"/>
+              <a:gd name="connsiteX1" fmla="*/ 7169335 w 7187261"/>
+              <a:gd name="connsiteY1" fmla="*/ 2328577 h 5150263"/>
+              <a:gd name="connsiteX2" fmla="*/ 7060845 w 7187261"/>
+              <a:gd name="connsiteY2" fmla="*/ 1661160 h 5150263"/>
+              <a:gd name="connsiteX3" fmla="*/ 6212263 w 7187261"/>
+              <a:gd name="connsiteY3" fmla="*/ 243840 h 5150263"/>
+              <a:gd name="connsiteX4" fmla="*/ 5953564 w 7187261"/>
+              <a:gd name="connsiteY4" fmla="*/ 0 h 5150263"/>
+              <a:gd name="connsiteX5" fmla="*/ 1408615 w 7187261"/>
+              <a:gd name="connsiteY5" fmla="*/ 0 h 5150263"/>
+              <a:gd name="connsiteX6" fmla="*/ 805111 w 7187261"/>
+              <a:gd name="connsiteY6" fmla="*/ 676275 h 5150263"/>
+              <a:gd name="connsiteX7" fmla="*/ 104928 w 7187261"/>
+              <a:gd name="connsiteY7" fmla="*/ 2183035 h 5150263"/>
+              <a:gd name="connsiteX8" fmla="*/ 51588 w 7187261"/>
+              <a:gd name="connsiteY8" fmla="*/ 2400014 h 5150263"/>
+              <a:gd name="connsiteX9" fmla="*/ 41301 w 7187261"/>
+              <a:gd name="connsiteY9" fmla="*/ 2424208 h 5150263"/>
+              <a:gd name="connsiteX10" fmla="*/ 119692 w 7187261"/>
+              <a:gd name="connsiteY10" fmla="*/ 1834801 h 5150263"/>
+              <a:gd name="connsiteX11" fmla="*/ 870071 w 7187261"/>
+              <a:gd name="connsiteY11" fmla="*/ 462248 h 5150263"/>
+              <a:gd name="connsiteX12" fmla="*/ 1389279 w 7187261"/>
+              <a:gd name="connsiteY12" fmla="*/ 476 h 5150263"/>
+              <a:gd name="connsiteX13" fmla="*/ 1320223 w 7187261"/>
+              <a:gd name="connsiteY13" fmla="*/ 476 h 5150263"/>
+              <a:gd name="connsiteX14" fmla="*/ 423158 w 7187261"/>
+              <a:gd name="connsiteY14" fmla="*/ 989743 h 5150263"/>
+              <a:gd name="connsiteX15" fmla="*/ 25585 w 7187261"/>
+              <a:gd name="connsiteY15" fmla="*/ 2113693 h 5150263"/>
+              <a:gd name="connsiteX16" fmla="*/ 2344 w 7187261"/>
+              <a:gd name="connsiteY16" fmla="*/ 2725865 h 5150263"/>
+              <a:gd name="connsiteX17" fmla="*/ 447256 w 7187261"/>
+              <a:gd name="connsiteY17" fmla="*/ 4210717 h 5150263"/>
+              <a:gd name="connsiteX18" fmla="*/ 1138962 w 7187261"/>
+              <a:gd name="connsiteY18" fmla="*/ 4988910 h 5150263"/>
+              <a:gd name="connsiteX19" fmla="*/ 1348512 w 7187261"/>
+              <a:gd name="connsiteY19" fmla="*/ 5146834 h 5150263"/>
+              <a:gd name="connsiteX20" fmla="*/ 1422712 w 7187261"/>
+              <a:gd name="connsiteY20" fmla="*/ 5146834 h 5150263"/>
+              <a:gd name="connsiteX21" fmla="*/ 480594 w 7187261"/>
+              <a:gd name="connsiteY21" fmla="*/ 4187952 h 5150263"/>
+              <a:gd name="connsiteX22" fmla="*/ 398679 w 7187261"/>
+              <a:gd name="connsiteY22" fmla="*/ 4046125 h 5150263"/>
+              <a:gd name="connsiteX23" fmla="*/ 411823 w 7187261"/>
+              <a:gd name="connsiteY23" fmla="*/ 4053078 h 5150263"/>
+              <a:gd name="connsiteX24" fmla="*/ 1439380 w 7187261"/>
+              <a:gd name="connsiteY24" fmla="*/ 5147405 h 5150263"/>
+              <a:gd name="connsiteX25" fmla="*/ 5710010 w 7187261"/>
+              <a:gd name="connsiteY25" fmla="*/ 5150263 h 5150263"/>
+              <a:gd name="connsiteX26" fmla="*/ 5999665 w 7187261"/>
+              <a:gd name="connsiteY26" fmla="*/ 4910900 h 5150263"/>
+              <a:gd name="connsiteX27" fmla="*/ 6954165 w 7187261"/>
+              <a:gd name="connsiteY27" fmla="*/ 3545777 h 5150263"/>
+              <a:gd name="connsiteX28" fmla="*/ 7137712 w 7187261"/>
+              <a:gd name="connsiteY28" fmla="*/ 2799207 h 5150263"/>
+              <a:gd name="connsiteX29" fmla="*/ 7142951 w 7187261"/>
+              <a:gd name="connsiteY29" fmla="*/ 2754535 h 5150263"/>
+              <a:gd name="connsiteX30" fmla="*/ 7149428 w 7187261"/>
+              <a:gd name="connsiteY30" fmla="*/ 2774823 h 5150263"/>
+              <a:gd name="connsiteX31" fmla="*/ 7066465 w 7187261"/>
+              <a:gd name="connsiteY31" fmla="*/ 3465672 h 5150263"/>
+              <a:gd name="connsiteX32" fmla="*/ 6452578 w 7187261"/>
+              <a:gd name="connsiteY32" fmla="*/ 4552760 h 5150263"/>
+              <a:gd name="connsiteX33" fmla="*/ 5752110 w 7187261"/>
+              <a:gd name="connsiteY33" fmla="*/ 5150263 h 5150263"/>
+              <a:gd name="connsiteX34" fmla="*/ 5827643 w 7187261"/>
+              <a:gd name="connsiteY34" fmla="*/ 5150263 h 5150263"/>
+              <a:gd name="connsiteX35" fmla="*/ 6642793 w 7187261"/>
+              <a:gd name="connsiteY35" fmla="*/ 4389406 h 5150263"/>
+              <a:gd name="connsiteX36" fmla="*/ 7102469 w 7187261"/>
+              <a:gd name="connsiteY36" fmla="*/ 3490817 h 5150263"/>
+              <a:gd name="connsiteX37" fmla="*/ 7187242 w 7187261"/>
+              <a:gd name="connsiteY37" fmla="*/ 2990183 h 5150263"/>
+              <a:gd name="connsiteX38" fmla="*/ 7178288 w 7187261"/>
+              <a:gd name="connsiteY38" fmla="*/ 2604802 h 5150263"/>
+              <a:gd name="connsiteX39" fmla="*/ 6342565 w 7187261"/>
+              <a:gd name="connsiteY39" fmla="*/ 441389 h 5150263"/>
+              <a:gd name="connsiteX40" fmla="*/ 7126567 w 7187261"/>
+              <a:gd name="connsiteY40" fmla="*/ 2355056 h 5150263"/>
+              <a:gd name="connsiteX41" fmla="*/ 6342565 w 7187261"/>
+              <a:gd name="connsiteY41" fmla="*/ 441389 h 5150263"/>
+            </a:gdLst>
+            <a:ahLst/>
+            <a:cxnLst>
+              <a:cxn ang="0">
+                <a:pos x="connsiteX0" y="connsiteY0"/>
+              </a:cxn>
+              <a:cxn ang="0">
+                <a:pos x="connsiteX1" y="connsiteY1"/>
+              </a:cxn>
+              <a:cxn ang="0">
+                <a:pos x="connsiteX2" y="connsiteY2"/>
+              </a:cxn>
+              <a:cxn ang="0">
+                <a:pos x="connsiteX3" y="connsiteY3"/>
+              </a:cxn>
+              <a:cxn ang="0">
+                <a:pos x="connsiteX4" y="connsiteY4"/>
+              </a:cxn>
+              <a:cxn ang="0">
+                <a:pos x="connsiteX5" y="connsiteY5"/>
+              </a:cxn>
+              <a:cxn ang="0">
+                <a:pos x="connsiteX6" y="connsiteY6"/>
+              </a:cxn>
+              <a:cxn ang="0">
+                <a:pos x="connsiteX7" y="connsiteY7"/>
+              </a:cxn>
+              <a:cxn ang="0">
+                <a:pos x="connsiteX8" y="connsiteY8"/>
+              </a:cxn>
+              <a:cxn ang="0">
+                <a:pos x="connsiteX9" y="connsiteY9"/>
+              </a:cxn>
+              <a:cxn ang="0">
+                <a:pos x="connsiteX10" y="connsiteY10"/>
+              </a:cxn>
+              <a:cxn ang="0">
+                <a:pos x="connsiteX11" y="connsiteY11"/>
+              </a:cxn>
+              <a:cxn ang="0">
+                <a:pos x="connsiteX12" y="connsiteY12"/>
+              </a:cxn>
+              <a:cxn ang="0">
+                <a:pos x="connsiteX13" y="connsiteY13"/>
+              </a:cxn>
+              <a:cxn ang="0">
+                <a:pos x="connsiteX14" y="connsiteY14"/>
+              </a:cxn>
+              <a:cxn ang="0">
+                <a:pos x="connsiteX15" y="connsiteY15"/>
+              </a:cxn>
+              <a:cxn ang="0">
+                <a:pos x="connsiteX16" y="connsiteY16"/>
+              </a:cxn>
+              <a:cxn ang="0">
+                <a:pos x="connsiteX17" y="connsiteY17"/>
+              </a:cxn>
+              <a:cxn ang="0">
+                <a:pos x="connsiteX18" y="connsiteY18"/>
+              </a:cxn>
+              <a:cxn ang="0">
+                <a:pos x="connsiteX19" y="connsiteY19"/>
+              </a:cxn>
+              <a:cxn ang="0">
+                <a:pos x="connsiteX20" y="connsiteY20"/>
+              </a:cxn>
+              <a:cxn ang="0">
+                <a:pos x="connsiteX21" y="connsiteY21"/>
+              </a:cxn>
+              <a:cxn ang="0">
+                <a:pos x="connsiteX22" y="connsiteY22"/>
+              </a:cxn>
+              <a:cxn ang="0">
+                <a:pos x="connsiteX23" y="connsiteY23"/>
+              </a:cxn>
+              <a:cxn ang="0">
+                <a:pos x="connsiteX24" y="connsiteY24"/>
+              </a:cxn>
+              <a:cxn ang="0">
+                <a:pos x="connsiteX25" y="connsiteY25"/>
+              </a:cxn>
+              <a:cxn ang="0">
+                <a:pos x="connsiteX26" y="connsiteY26"/>
+              </a:cxn>
+              <a:cxn ang="0">
+                <a:pos x="connsiteX27" y="connsiteY27"/>
+              </a:cxn>
+              <a:cxn ang="0">
+                <a:pos x="connsiteX28" y="connsiteY28"/>
+              </a:cxn>
+              <a:cxn ang="0">
+                <a:pos x="connsiteX29" y="connsiteY29"/>
+              </a:cxn>
+              <a:cxn ang="0">
+                <a:pos x="connsiteX30" y="connsiteY30"/>
+              </a:cxn>
+              <a:cxn ang="0">
+                <a:pos x="connsiteX31" y="connsiteY31"/>
+              </a:cxn>
+              <a:cxn ang="0">
+                <a:pos x="connsiteX32" y="connsiteY32"/>
+              </a:cxn>
+              <a:cxn ang="0">
+                <a:pos x="connsiteX33" y="connsiteY33"/>
+              </a:cxn>
+              <a:cxn ang="0">
+                <a:pos x="connsiteX34" y="connsiteY34"/>
+              </a:cxn>
+              <a:cxn ang="0">
+                <a:pos x="connsiteX35" y="connsiteY35"/>
+              </a:cxn>
+              <a:cxn ang="0">
+                <a:pos x="connsiteX36" y="connsiteY36"/>
+              </a:cxn>
+              <a:cxn ang="0">
+                <a:pos x="connsiteX37" y="connsiteY37"/>
+              </a:cxn>
+              <a:cxn ang="0">
+                <a:pos x="connsiteX38" y="connsiteY38"/>
+              </a:cxn>
+              <a:cxn ang="0">
+                <a:pos x="connsiteX39" y="connsiteY39"/>
+              </a:cxn>
+              <a:cxn ang="0">
+                <a:pos x="connsiteX40" y="connsiteY40"/>
+              </a:cxn>
+              <a:cxn ang="0">
+                <a:pos x="connsiteX41" y="connsiteY41"/>
+              </a:cxn>
+            </a:cxnLst>
+            <a:rect l="l" t="t" r="r" b="b"/>
+            <a:pathLst>
+              <a:path w="7187261" h="5150263">
+                <a:moveTo>
+                  <a:pt x="7178288" y="2604802"/>
+                </a:moveTo>
+                <a:cubicBezTo>
+                  <a:pt x="7168763" y="2513076"/>
+                  <a:pt x="7174478" y="2420684"/>
+                  <a:pt x="7169335" y="2328577"/>
+                </a:cubicBezTo>
+                <a:cubicBezTo>
+                  <a:pt x="7156952" y="2102882"/>
+                  <a:pt x="7120586" y="1879149"/>
+                  <a:pt x="7060845" y="1661160"/>
+                </a:cubicBezTo>
+                <a:cubicBezTo>
+                  <a:pt x="6910588" y="1121007"/>
+                  <a:pt x="6617428" y="631374"/>
+                  <a:pt x="6212263" y="243840"/>
+                </a:cubicBezTo>
+                <a:cubicBezTo>
+                  <a:pt x="6126538" y="162496"/>
+                  <a:pt x="6040813" y="80201"/>
+                  <a:pt x="5953564" y="0"/>
+                </a:cubicBezTo>
+                <a:lnTo>
+                  <a:pt x="1408615" y="0"/>
+                </a:lnTo>
+                <a:cubicBezTo>
+                  <a:pt x="1180967" y="200316"/>
+                  <a:pt x="978332" y="427387"/>
+                  <a:pt x="805111" y="676275"/>
+                </a:cubicBezTo>
+                <a:cubicBezTo>
+                  <a:pt x="481261" y="1136523"/>
+                  <a:pt x="252089" y="1640872"/>
+                  <a:pt x="104928" y="2183035"/>
+                </a:cubicBezTo>
+                <a:cubicBezTo>
+                  <a:pt x="85878" y="2254853"/>
+                  <a:pt x="69495" y="2327720"/>
+                  <a:pt x="51588" y="2400014"/>
+                </a:cubicBezTo>
+                <a:cubicBezTo>
+                  <a:pt x="49683" y="2407634"/>
+                  <a:pt x="51588" y="2416969"/>
+                  <a:pt x="41301" y="2424208"/>
+                </a:cubicBezTo>
+                <a:cubicBezTo>
+                  <a:pt x="45900" y="2225469"/>
+                  <a:pt x="72186" y="2027834"/>
+                  <a:pt x="119692" y="1834801"/>
+                </a:cubicBezTo>
+                <a:cubicBezTo>
+                  <a:pt x="247993" y="1310926"/>
+                  <a:pt x="506121" y="857726"/>
+                  <a:pt x="870071" y="462248"/>
+                </a:cubicBezTo>
+                <a:cubicBezTo>
+                  <a:pt x="1027729" y="291823"/>
+                  <a:pt x="1201617" y="137169"/>
+                  <a:pt x="1389279" y="476"/>
+                </a:cubicBezTo>
+                <a:lnTo>
+                  <a:pt x="1320223" y="476"/>
+                </a:lnTo>
+                <a:cubicBezTo>
+                  <a:pt x="960844" y="274320"/>
+                  <a:pt x="656330" y="599123"/>
+                  <a:pt x="423158" y="989743"/>
+                </a:cubicBezTo>
+                <a:cubicBezTo>
+                  <a:pt x="215608" y="1337596"/>
+                  <a:pt x="80258" y="1711357"/>
+                  <a:pt x="25585" y="2113693"/>
+                </a:cubicBezTo>
+                <a:cubicBezTo>
+                  <a:pt x="-2705" y="2316480"/>
+                  <a:pt x="-2228" y="2521077"/>
+                  <a:pt x="2344" y="2725865"/>
+                </a:cubicBezTo>
+                <a:cubicBezTo>
+                  <a:pt x="14155" y="3261932"/>
+                  <a:pt x="170650" y="3754565"/>
+                  <a:pt x="447256" y="4210717"/>
+                </a:cubicBezTo>
+                <a:cubicBezTo>
+                  <a:pt x="629851" y="4511612"/>
+                  <a:pt x="866356" y="4767167"/>
+                  <a:pt x="1138962" y="4988910"/>
+                </a:cubicBezTo>
+                <a:cubicBezTo>
+                  <a:pt x="1207161" y="5044345"/>
+                  <a:pt x="1277008" y="5096990"/>
+                  <a:pt x="1348512" y="5146834"/>
+                </a:cubicBezTo>
+                <a:lnTo>
+                  <a:pt x="1422712" y="5146834"/>
+                </a:lnTo>
+                <a:cubicBezTo>
+                  <a:pt x="1043426" y="4892802"/>
+                  <a:pt x="724720" y="4577334"/>
+                  <a:pt x="480594" y="4187952"/>
+                </a:cubicBezTo>
+                <a:cubicBezTo>
+                  <a:pt x="452019" y="4141851"/>
+                  <a:pt x="423444" y="4095179"/>
+                  <a:pt x="398679" y="4046125"/>
+                </a:cubicBezTo>
+                <a:cubicBezTo>
+                  <a:pt x="407442" y="4043267"/>
+                  <a:pt x="409156" y="4048982"/>
+                  <a:pt x="411823" y="4053078"/>
+                </a:cubicBezTo>
+                <a:cubicBezTo>
+                  <a:pt x="683572" y="4484656"/>
+                  <a:pt x="1033139" y="4842701"/>
+                  <a:pt x="1439380" y="5147405"/>
+                </a:cubicBezTo>
+                <a:lnTo>
+                  <a:pt x="5710010" y="5150263"/>
+                </a:lnTo>
+                <a:cubicBezTo>
+                  <a:pt x="5810594" y="5075482"/>
+                  <a:pt x="5907272" y="4995587"/>
+                  <a:pt x="5999665" y="4910900"/>
+                </a:cubicBezTo>
+                <a:cubicBezTo>
+                  <a:pt x="6418765" y="4526661"/>
+                  <a:pt x="6746901" y="4078129"/>
+                  <a:pt x="6954165" y="3545777"/>
+                </a:cubicBezTo>
+                <a:cubicBezTo>
+                  <a:pt x="7048234" y="3306175"/>
+                  <a:pt x="7109956" y="3055115"/>
+                  <a:pt x="7137712" y="2799207"/>
+                </a:cubicBezTo>
+                <a:cubicBezTo>
+                  <a:pt x="7139236" y="2784920"/>
+                  <a:pt x="7141046" y="2770632"/>
+                  <a:pt x="7142951" y="2754535"/>
+                </a:cubicBezTo>
+                <a:cubicBezTo>
+                  <a:pt x="7151714" y="2760440"/>
+                  <a:pt x="7149237" y="2768441"/>
+                  <a:pt x="7149428" y="2774823"/>
+                </a:cubicBezTo>
+                <a:cubicBezTo>
+                  <a:pt x="7156743" y="3007967"/>
+                  <a:pt x="7128777" y="3240881"/>
+                  <a:pt x="7066465" y="3465672"/>
+                </a:cubicBezTo>
+                <a:cubicBezTo>
+                  <a:pt x="6952165" y="3878580"/>
+                  <a:pt x="6737948" y="4235863"/>
+                  <a:pt x="6452578" y="4552760"/>
+                </a:cubicBezTo>
+                <a:cubicBezTo>
+                  <a:pt x="6244553" y="4783836"/>
+                  <a:pt x="6008809" y="4980242"/>
+                  <a:pt x="5752110" y="5150263"/>
+                </a:cubicBezTo>
+                <a:lnTo>
+                  <a:pt x="5827643" y="5150263"/>
+                </a:lnTo>
+                <a:cubicBezTo>
+                  <a:pt x="6136539" y="4938904"/>
+                  <a:pt x="6412192" y="4689348"/>
+                  <a:pt x="6642793" y="4389406"/>
+                </a:cubicBezTo>
+                <a:cubicBezTo>
+                  <a:pt x="6851295" y="4118324"/>
+                  <a:pt x="7009125" y="3820859"/>
+                  <a:pt x="7102469" y="3490817"/>
+                </a:cubicBezTo>
+                <a:cubicBezTo>
+                  <a:pt x="7148646" y="3327473"/>
+                  <a:pt x="7177069" y="3159624"/>
+                  <a:pt x="7187242" y="2990183"/>
+                </a:cubicBezTo>
+                <a:cubicBezTo>
+                  <a:pt x="7187623" y="2984087"/>
+                  <a:pt x="7182384" y="2642330"/>
+                  <a:pt x="7178288" y="2604802"/>
+                </a:cubicBezTo>
+                <a:close/>
+                <a:moveTo>
+                  <a:pt x="6342565" y="441389"/>
+                </a:moveTo>
+                <a:cubicBezTo>
+                  <a:pt x="6829797" y="986533"/>
+                  <a:pt x="7091135" y="1624422"/>
+                  <a:pt x="7126567" y="2355056"/>
+                </a:cubicBezTo>
+                <a:cubicBezTo>
+                  <a:pt x="7001123" y="1661827"/>
+                  <a:pt x="6756426" y="1017365"/>
+                  <a:pt x="6342565" y="441389"/>
+                </a:cubicBezTo>
+                <a:close/>
+              </a:path>
+            </a:pathLst>
+          </a:custGeom>
+          <a:solidFill>
+            <a:schemeClr val="accent2"/>
+          </a:solidFill>
+          <a:ln w="9525" cap="flat">
+            <a:noFill/>
+            <a:prstDash val="solid"/>
+            <a:miter/>
+          </a:ln>
+        </p:spPr>
+        <p:txBody>
+          <a:bodyPr rtlCol="0" anchor="ctr"/>
+          <a:lstStyle/>
+          <a:p>
+            <a:endParaRPr lang="en-US"/>
+          </a:p>
+        </p:txBody>
+      </p:sp>
+      <p:sp>
+        <p:nvSpPr>
+          <p:cNvPr id="2" name="Title 1">
+            <a:extLst>
+              <a:ext uri="{FF2B5EF4-FFF2-40B4-BE49-F238E27FC236}">
+                <a16:creationId xmlns:a16="http://schemas.microsoft.com/office/drawing/2014/main" id="{14A1F042-E4D7-BF49-E82F-204BC69BC57C}"/>
+              </a:ext>
+            </a:extLst>
+          </p:cNvPr>
+          <p:cNvSpPr>
+            <a:spLocks noGrp="1"/>
+          </p:cNvSpPr>
+          <p:nvPr>
+            <p:ph type="ctrTitle"/>
+          </p:nvPr>
+        </p:nvSpPr>
+        <p:spPr>
+          <a:xfrm>
+            <a:off x="2558716" y="955309"/>
+            <a:ext cx="7074568" cy="2898975"/>
+          </a:xfrm>
+        </p:spPr>
+        <p:txBody>
+          <a:bodyPr>
+            <a:normAutofit/>
+          </a:bodyPr>
+          <a:lstStyle/>
+          <a:p>
+            <a:r>
+              <a:rPr lang="en-US" sz="6600">
+                <a:solidFill>
+                  <a:srgbClr val="FFFFFF"/>
+                </a:solidFill>
+              </a:rPr>
+              <a:t>Intro to Github workshop</a:t>
+            </a:r>
+            <a:endParaRPr lang="en-ZA" sz="6600">
+              <a:solidFill>
+                <a:srgbClr val="FFFFFF"/>
+              </a:solidFill>
+            </a:endParaRPr>
+          </a:p>
+        </p:txBody>
+      </p:sp>
+      <p:sp>
+        <p:nvSpPr>
+          <p:cNvPr id="3" name="TextBox 2">
+            <a:extLst>
+              <a:ext uri="{FF2B5EF4-FFF2-40B4-BE49-F238E27FC236}">
+                <a16:creationId xmlns:a16="http://schemas.microsoft.com/office/drawing/2014/main" id="{F1DA2FFC-6FF6-A48A-4924-76043C6B835A}"/>
+              </a:ext>
+            </a:extLst>
+          </p:cNvPr>
+          <p:cNvSpPr txBox="1"/>
+          <p:nvPr/>
+        </p:nvSpPr>
+        <p:spPr>
+          <a:xfrm>
+            <a:off x="2634916" y="4533813"/>
+            <a:ext cx="6930189" cy="938463"/>
           </a:xfrm>
           <a:prstGeom prst="rect">
             <a:avLst/>
           </a:prstGeom>
         </p:spPr>
-      </p:pic>
+        <p:txBody>
+          <a:bodyPr rtlCol="0">
+            <a:normAutofit/>
+          </a:bodyPr>
+          <a:lstStyle/>
+          <a:p>
+            <a:pPr>
+              <a:spcAft>
+                <a:spcPts val="600"/>
+              </a:spcAft>
+            </a:pPr>
+            <a:r>
+              <a:rPr lang="en-US" dirty="0">
+                <a:solidFill>
+                  <a:srgbClr val="FFFFFF"/>
+                </a:solidFill>
+              </a:rPr>
+              <a:t>Thanks,</a:t>
+            </a:r>
+          </a:p>
+          <a:p>
+            <a:pPr>
+              <a:spcAft>
+                <a:spcPts val="600"/>
+              </a:spcAft>
+            </a:pPr>
+            <a:r>
+              <a:rPr lang="en-US" dirty="0">
+                <a:solidFill>
+                  <a:srgbClr val="FFFFFF"/>
+                </a:solidFill>
+              </a:rPr>
+              <a:t>Francesca Middleton</a:t>
+            </a:r>
+            <a:endParaRPr lang="en-ZA" dirty="0">
+              <a:solidFill>
+                <a:srgbClr val="FFFFFF"/>
+              </a:solidFill>
+            </a:endParaRPr>
+          </a:p>
+        </p:txBody>
+      </p:sp>
+      <p:sp>
+        <p:nvSpPr>
+          <p:cNvPr id="12" name="sketch line">
+            <a:extLst>
+              <a:ext uri="{FF2B5EF4-FFF2-40B4-BE49-F238E27FC236}">
+                <a16:creationId xmlns:a16="http://schemas.microsoft.com/office/drawing/2014/main" id="{41F77738-2AF0-4750-A0C7-F97C2C17590E}"/>
+              </a:ext>
+              <a:ext uri="{C183D7F6-B498-43B3-948B-1728B52AA6E4}">
+                <adec:decorative xmlns:adec="http://schemas.microsoft.com/office/drawing/2017/decorative" val="1"/>
+              </a:ext>
+            </a:extLst>
+          </p:cNvPr>
+          <p:cNvSpPr>
+            <a:spLocks noGrp="1" noRot="1" noChangeAspect="1" noMove="1" noResize="1" noEditPoints="1" noAdjustHandles="1" noChangeArrowheads="1" noChangeShapeType="1" noTextEdit="1"/>
+          </p:cNvSpPr>
+          <p:nvPr>
+            <p:extLst>
+              <p:ext uri="{386F3935-93C4-4BCD-93E2-E3B085C9AB24}">
+                <p16:designElem xmlns:p16="http://schemas.microsoft.com/office/powerpoint/2015/main" val="1"/>
+              </p:ext>
+            </p:extLst>
+          </p:nvPr>
+        </p:nvSpPr>
+        <p:spPr>
+          <a:xfrm>
+            <a:off x="3974206" y="4173498"/>
+            <a:ext cx="4243589" cy="18288"/>
+          </a:xfrm>
+          <a:custGeom>
+            <a:avLst/>
+            <a:gdLst>
+              <a:gd name="csX0" fmla="*/ 0 w 4243589"/>
+              <a:gd name="csY0" fmla="*/ 0 h 18288"/>
+              <a:gd name="csX1" fmla="*/ 563791 w 4243589"/>
+              <a:gd name="csY1" fmla="*/ 0 h 18288"/>
+              <a:gd name="csX2" fmla="*/ 1042710 w 4243589"/>
+              <a:gd name="csY2" fmla="*/ 0 h 18288"/>
+              <a:gd name="csX3" fmla="*/ 1564066 w 4243589"/>
+              <a:gd name="csY3" fmla="*/ 0 h 18288"/>
+              <a:gd name="csX4" fmla="*/ 2212729 w 4243589"/>
+              <a:gd name="csY4" fmla="*/ 0 h 18288"/>
+              <a:gd name="csX5" fmla="*/ 2776520 w 4243589"/>
+              <a:gd name="csY5" fmla="*/ 0 h 18288"/>
+              <a:gd name="csX6" fmla="*/ 3297875 w 4243589"/>
+              <a:gd name="csY6" fmla="*/ 0 h 18288"/>
+              <a:gd name="csX7" fmla="*/ 4243589 w 4243589"/>
+              <a:gd name="csY7" fmla="*/ 0 h 18288"/>
+              <a:gd name="csX8" fmla="*/ 4243589 w 4243589"/>
+              <a:gd name="csY8" fmla="*/ 18288 h 18288"/>
+              <a:gd name="csX9" fmla="*/ 3637362 w 4243589"/>
+              <a:gd name="csY9" fmla="*/ 18288 h 18288"/>
+              <a:gd name="csX10" fmla="*/ 3116007 w 4243589"/>
+              <a:gd name="csY10" fmla="*/ 18288 h 18288"/>
+              <a:gd name="csX11" fmla="*/ 2424908 w 4243589"/>
+              <a:gd name="csY11" fmla="*/ 18288 h 18288"/>
+              <a:gd name="csX12" fmla="*/ 1861117 w 4243589"/>
+              <a:gd name="csY12" fmla="*/ 18288 h 18288"/>
+              <a:gd name="csX13" fmla="*/ 1382198 w 4243589"/>
+              <a:gd name="csY13" fmla="*/ 18288 h 18288"/>
+              <a:gd name="csX14" fmla="*/ 733535 w 4243589"/>
+              <a:gd name="csY14" fmla="*/ 18288 h 18288"/>
+              <a:gd name="csX15" fmla="*/ 0 w 4243589"/>
+              <a:gd name="csY15" fmla="*/ 18288 h 18288"/>
+              <a:gd name="csX16" fmla="*/ 0 w 4243589"/>
+              <a:gd name="csY16" fmla="*/ 0 h 18288"/>
+            </a:gdLst>
+            <a:ahLst/>
+            <a:cxnLst>
+              <a:cxn ang="0">
+                <a:pos x="csX0" y="csY0"/>
+              </a:cxn>
+              <a:cxn ang="0">
+                <a:pos x="csX1" y="csY1"/>
+              </a:cxn>
+              <a:cxn ang="0">
+                <a:pos x="csX2" y="csY2"/>
+              </a:cxn>
+              <a:cxn ang="0">
+                <a:pos x="csX3" y="csY3"/>
+              </a:cxn>
+              <a:cxn ang="0">
+                <a:pos x="csX4" y="csY4"/>
+              </a:cxn>
+              <a:cxn ang="0">
+                <a:pos x="csX5" y="csY5"/>
+              </a:cxn>
+              <a:cxn ang="0">
+                <a:pos x="csX6" y="csY6"/>
+              </a:cxn>
+              <a:cxn ang="0">
+                <a:pos x="csX7" y="csY7"/>
+              </a:cxn>
+              <a:cxn ang="0">
+                <a:pos x="csX8" y="csY8"/>
+              </a:cxn>
+              <a:cxn ang="0">
+                <a:pos x="csX9" y="csY9"/>
+              </a:cxn>
+              <a:cxn ang="0">
+                <a:pos x="csX10" y="csY10"/>
+              </a:cxn>
+              <a:cxn ang="0">
+                <a:pos x="csX11" y="csY11"/>
+              </a:cxn>
+              <a:cxn ang="0">
+                <a:pos x="csX12" y="csY12"/>
+              </a:cxn>
+              <a:cxn ang="0">
+                <a:pos x="csX13" y="csY13"/>
+              </a:cxn>
+              <a:cxn ang="0">
+                <a:pos x="csX14" y="csY14"/>
+              </a:cxn>
+              <a:cxn ang="0">
+                <a:pos x="csX15" y="csY15"/>
+              </a:cxn>
+              <a:cxn ang="0">
+                <a:pos x="csX16" y="csY16"/>
+              </a:cxn>
+            </a:cxnLst>
+            <a:rect l="l" t="t" r="r" b="b"/>
+            <a:pathLst>
+              <a:path w="4243589" h="18288" fill="none" extrusionOk="0">
+                <a:moveTo>
+                  <a:pt x="0" y="0"/>
+                </a:moveTo>
+                <a:cubicBezTo>
+                  <a:pt x="157351" y="-15653"/>
+                  <a:pt x="378877" y="-5828"/>
+                  <a:pt x="563791" y="0"/>
+                </a:cubicBezTo>
+                <a:cubicBezTo>
+                  <a:pt x="748705" y="5828"/>
+                  <a:pt x="905659" y="-5525"/>
+                  <a:pt x="1042710" y="0"/>
+                </a:cubicBezTo>
+                <a:cubicBezTo>
+                  <a:pt x="1179761" y="5525"/>
+                  <a:pt x="1356845" y="-21288"/>
+                  <a:pt x="1564066" y="0"/>
+                </a:cubicBezTo>
+                <a:cubicBezTo>
+                  <a:pt x="1771287" y="21288"/>
+                  <a:pt x="1912099" y="25135"/>
+                  <a:pt x="2212729" y="0"/>
+                </a:cubicBezTo>
+                <a:cubicBezTo>
+                  <a:pt x="2513359" y="-25135"/>
+                  <a:pt x="2514918" y="-27119"/>
+                  <a:pt x="2776520" y="0"/>
+                </a:cubicBezTo>
+                <a:cubicBezTo>
+                  <a:pt x="3038122" y="27119"/>
+                  <a:pt x="3178771" y="18116"/>
+                  <a:pt x="3297875" y="0"/>
+                </a:cubicBezTo>
+                <a:cubicBezTo>
+                  <a:pt x="3416980" y="-18116"/>
+                  <a:pt x="4012240" y="-40869"/>
+                  <a:pt x="4243589" y="0"/>
+                </a:cubicBezTo>
+                <a:cubicBezTo>
+                  <a:pt x="4243987" y="7429"/>
+                  <a:pt x="4243569" y="10822"/>
+                  <a:pt x="4243589" y="18288"/>
+                </a:cubicBezTo>
+                <a:cubicBezTo>
+                  <a:pt x="4112949" y="-2855"/>
+                  <a:pt x="3928037" y="1831"/>
+                  <a:pt x="3637362" y="18288"/>
+                </a:cubicBezTo>
+                <a:cubicBezTo>
+                  <a:pt x="3346687" y="34745"/>
+                  <a:pt x="3254446" y="26669"/>
+                  <a:pt x="3116007" y="18288"/>
+                </a:cubicBezTo>
+                <a:cubicBezTo>
+                  <a:pt x="2977569" y="9907"/>
+                  <a:pt x="2620228" y="28873"/>
+                  <a:pt x="2424908" y="18288"/>
+                </a:cubicBezTo>
+                <a:cubicBezTo>
+                  <a:pt x="2229588" y="7703"/>
+                  <a:pt x="2088287" y="-3854"/>
+                  <a:pt x="1861117" y="18288"/>
+                </a:cubicBezTo>
+                <a:cubicBezTo>
+                  <a:pt x="1633947" y="40430"/>
+                  <a:pt x="1502447" y="-871"/>
+                  <a:pt x="1382198" y="18288"/>
+                </a:cubicBezTo>
+                <a:cubicBezTo>
+                  <a:pt x="1261949" y="37447"/>
+                  <a:pt x="1045440" y="28353"/>
+                  <a:pt x="733535" y="18288"/>
+                </a:cubicBezTo>
+                <a:cubicBezTo>
+                  <a:pt x="421630" y="8223"/>
+                  <a:pt x="341257" y="-18359"/>
+                  <a:pt x="0" y="18288"/>
+                </a:cubicBezTo>
+                <a:cubicBezTo>
+                  <a:pt x="-591" y="13205"/>
+                  <a:pt x="-663" y="6329"/>
+                  <a:pt x="0" y="0"/>
+                </a:cubicBezTo>
+                <a:close/>
+              </a:path>
+              <a:path w="4243589" h="18288" stroke="0" extrusionOk="0">
+                <a:moveTo>
+                  <a:pt x="0" y="0"/>
+                </a:moveTo>
+                <a:cubicBezTo>
+                  <a:pt x="128164" y="17204"/>
+                  <a:pt x="312653" y="1129"/>
+                  <a:pt x="563791" y="0"/>
+                </a:cubicBezTo>
+                <a:cubicBezTo>
+                  <a:pt x="814929" y="-1129"/>
+                  <a:pt x="837271" y="8503"/>
+                  <a:pt x="1042710" y="0"/>
+                </a:cubicBezTo>
+                <a:cubicBezTo>
+                  <a:pt x="1248149" y="-8503"/>
+                  <a:pt x="1588432" y="-28862"/>
+                  <a:pt x="1733809" y="0"/>
+                </a:cubicBezTo>
+                <a:cubicBezTo>
+                  <a:pt x="1879186" y="28862"/>
+                  <a:pt x="2052815" y="5974"/>
+                  <a:pt x="2297600" y="0"/>
+                </a:cubicBezTo>
+                <a:cubicBezTo>
+                  <a:pt x="2542385" y="-5974"/>
+                  <a:pt x="2699960" y="-23550"/>
+                  <a:pt x="2861391" y="0"/>
+                </a:cubicBezTo>
+                <a:cubicBezTo>
+                  <a:pt x="3022822" y="23550"/>
+                  <a:pt x="3390411" y="25272"/>
+                  <a:pt x="3552490" y="0"/>
+                </a:cubicBezTo>
+                <a:cubicBezTo>
+                  <a:pt x="3714569" y="-25272"/>
+                  <a:pt x="3950585" y="-31327"/>
+                  <a:pt x="4243589" y="0"/>
+                </a:cubicBezTo>
+                <a:cubicBezTo>
+                  <a:pt x="4242703" y="5429"/>
+                  <a:pt x="4244410" y="14046"/>
+                  <a:pt x="4243589" y="18288"/>
+                </a:cubicBezTo>
+                <a:cubicBezTo>
+                  <a:pt x="4130424" y="-1240"/>
+                  <a:pt x="3932803" y="42249"/>
+                  <a:pt x="3722234" y="18288"/>
+                </a:cubicBezTo>
+                <a:cubicBezTo>
+                  <a:pt x="3511665" y="-5673"/>
+                  <a:pt x="3269903" y="45994"/>
+                  <a:pt x="3116007" y="18288"/>
+                </a:cubicBezTo>
+                <a:cubicBezTo>
+                  <a:pt x="2962111" y="-9418"/>
+                  <a:pt x="2744280" y="23224"/>
+                  <a:pt x="2509780" y="18288"/>
+                </a:cubicBezTo>
+                <a:cubicBezTo>
+                  <a:pt x="2275280" y="13352"/>
+                  <a:pt x="2066059" y="43664"/>
+                  <a:pt x="1945989" y="18288"/>
+                </a:cubicBezTo>
+                <a:cubicBezTo>
+                  <a:pt x="1825919" y="-7088"/>
+                  <a:pt x="1407329" y="12616"/>
+                  <a:pt x="1254890" y="18288"/>
+                </a:cubicBezTo>
+                <a:cubicBezTo>
+                  <a:pt x="1102451" y="23960"/>
+                  <a:pt x="837950" y="31673"/>
+                  <a:pt x="563791" y="18288"/>
+                </a:cubicBezTo>
+                <a:cubicBezTo>
+                  <a:pt x="289632" y="4903"/>
+                  <a:pt x="132768" y="7105"/>
+                  <a:pt x="0" y="18288"/>
+                </a:cubicBezTo>
+                <a:cubicBezTo>
+                  <a:pt x="668" y="13665"/>
+                  <a:pt x="578" y="5675"/>
+                  <a:pt x="0" y="0"/>
+                </a:cubicBezTo>
+                <a:close/>
+              </a:path>
+            </a:pathLst>
+          </a:custGeom>
+          <a:solidFill>
+            <a:srgbClr val="FFFFFF"/>
+          </a:solidFill>
+          <a:ln w="41275" cap="rnd">
+            <a:solidFill>
+              <a:srgbClr val="FFFFFF"/>
+            </a:solidFill>
+            <a:round/>
+            <a:extLst>
+              <a:ext uri="{C807C97D-BFC1-408E-A445-0C87EB9F89A2}">
+                <ask:lineSketchStyleProps xmlns:ask="http://schemas.microsoft.com/office/drawing/2018/sketchyshapes" sd="1219033472">
+                  <a:prstGeom prst="rect">
+                    <a:avLst/>
+                  </a:prstGeom>
+                  <ask:type>
+                    <ask:lineSketchFreehand/>
+                  </ask:type>
+                </ask:lineSketchStyleProps>
+              </a:ext>
+            </a:extLst>
+          </a:ln>
+        </p:spPr>
+        <p:style>
+          <a:lnRef idx="2">
+            <a:schemeClr val="accent1">
+              <a:shade val="50000"/>
+            </a:schemeClr>
+          </a:lnRef>
+          <a:fillRef idx="1">
+            <a:schemeClr val="accent1"/>
+          </a:fillRef>
+          <a:effectRef idx="0">
+            <a:schemeClr val="accent1"/>
+          </a:effectRef>
+          <a:fontRef idx="minor">
+            <a:schemeClr val="lt1"/>
+          </a:fontRef>
+        </p:style>
+        <p:txBody>
+          <a:bodyPr rtlCol="0" anchor="ctr"/>
+          <a:lstStyle/>
+          <a:p>
+            <a:pPr algn="ctr"/>
+            <a:endParaRPr lang="en-US"/>
+          </a:p>
+        </p:txBody>
+      </p:sp>
     </p:spTree>
     <p:extLst>
       <p:ext uri="{BB962C8B-B14F-4D97-AF65-F5344CB8AC3E}">
-        <p14:creationId xmlns:p14="http://schemas.microsoft.com/office/powerpoint/2010/main" val="219079411"/>
+        <p14:creationId xmlns:p14="http://schemas.microsoft.com/office/powerpoint/2010/main" val="3793282809"/>
       </p:ext>
     </p:extLst>
   </p:cSld>
   <p:clrMapOvr>
     <a:masterClrMapping/>
   </p:clrMapOvr>
-</p:sld>
-</file>
-
-<file path=ppt/slides/slide9.xml><?xml version="1.0" encoding="utf-8"?>
-<p:sld xmlns:a="http://schemas.openxmlformats.org/drawingml/2006/main" xmlns:r="http://schemas.openxmlformats.org/officeDocument/2006/relationships" xmlns:p="http://schemas.openxmlformats.org/presentationml/2006/main">
-  <p:cSld>
-    <p:spTree>
-      <p:nvGrpSpPr>
-        <p:cNvPr id="1" name=""/>
-        <p:cNvGrpSpPr/>
-        <p:nvPr/>
-      </p:nvGrpSpPr>
-      <p:grpSpPr>
-        <a:xfrm>
-          <a:off x="0" y="0"/>
-          <a:ext cx="0" cy="0"/>
-          <a:chOff x="0" y="0"/>
-          <a:chExt cx="0" cy="0"/>
-        </a:xfrm>
-      </p:grpSpPr>
-      <p:pic>
-        <p:nvPicPr>
-          <p:cNvPr id="3" name="Picture 2" descr="The image is a GitHub repository page for a project named 'hello-ml-research-group', which includes sections for code, README, custom properties, and contributor information.&#10;&#10;AI-generated content may be incorrect.">
-            <a:extLst>
-              <a:ext uri="{FF2B5EF4-FFF2-40B4-BE49-F238E27FC236}">
-                <a16:creationId xmlns:a16="http://schemas.microsoft.com/office/drawing/2014/main" id="{F9DD3257-B768-22D2-B6AC-D3012B3E101B}"/>
-              </a:ext>
-            </a:extLst>
-          </p:cNvPr>
-          <p:cNvPicPr>
-            <a:picLocks noChangeAspect="1"/>
-          </p:cNvPicPr>
-          <p:nvPr/>
-        </p:nvPicPr>
-        <p:blipFill>
-          <a:blip r:embed="rId2"/>
-          <a:stretch>
-            <a:fillRect/>
-          </a:stretch>
-        </p:blipFill>
-        <p:spPr>
-          <a:xfrm>
-            <a:off x="432511" y="0"/>
-            <a:ext cx="11326978" cy="6858000"/>
-          </a:xfrm>
-          <a:prstGeom prst="rect">
-            <a:avLst/>
-          </a:prstGeom>
-        </p:spPr>
-      </p:pic>
-    </p:spTree>
-    <p:extLst>
-      <p:ext uri="{BB962C8B-B14F-4D97-AF65-F5344CB8AC3E}">
-        <p14:creationId xmlns:p14="http://schemas.microsoft.com/office/powerpoint/2010/main" val="1802988582"/>
-      </p:ext>
-    </p:extLst>
-  </p:cSld>
-  <p:clrMapOvr>
-    <a:masterClrMapping/>
-  </p:clrMapOvr>
+  <p:timing>
+    <p:tnLst>
+      <p:par>
+        <p:cTn id="1" dur="indefinite" restart="never" nodeType="tmRoot">
+          <p:childTnLst>
+            <p:seq concurrent="1" nextAc="seek">
+              <p:cTn id="2" dur="indefinite" nodeType="mainSeq">
+                <p:childTnLst>
+                  <p:par>
+                    <p:cTn id="3" fill="hold">
+                      <p:stCondLst>
+                        <p:cond delay="indefinite"/>
+                        <p:cond evt="onBegin" delay="0">
+                          <p:tn val="2"/>
+                        </p:cond>
+                      </p:stCondLst>
+                      <p:childTnLst>
+                        <p:par>
+                          <p:cTn id="4" fill="hold">
+                            <p:stCondLst>
+                              <p:cond delay="0"/>
+                            </p:stCondLst>
+                            <p:childTnLst>
+                              <p:par>
+                                <p:cTn id="5" presetID="10" presetClass="entr" presetSubtype="0" fill="hold" grpId="0" nodeType="withEffect">
+                                  <p:stCondLst>
+                                    <p:cond delay="500"/>
+                                  </p:stCondLst>
+                                  <p:iterate>
+                                    <p:tmPct val="10000"/>
+                                  </p:iterate>
+                                  <p:childTnLst>
+                                    <p:set>
+                                      <p:cBhvr>
+                                        <p:cTn id="6" dur="1" fill="hold">
+                                          <p:stCondLst>
+                                            <p:cond delay="0"/>
+                                          </p:stCondLst>
+                                        </p:cTn>
+                                        <p:tgtEl>
+                                          <p:spTgt spid="2"/>
+                                        </p:tgtEl>
+                                        <p:attrNameLst>
+                                          <p:attrName>style.visibility</p:attrName>
+                                        </p:attrNameLst>
+                                      </p:cBhvr>
+                                      <p:to>
+                                        <p:strVal val="visible"/>
+                                      </p:to>
+                                    </p:set>
+                                    <p:animEffect transition="in" filter="fade">
+                                      <p:cBhvr>
+                                        <p:cTn id="7" dur="700"/>
+                                        <p:tgtEl>
+                                          <p:spTgt spid="2"/>
+                                        </p:tgtEl>
+                                      </p:cBhvr>
+                                    </p:animEffect>
+                                  </p:childTnLst>
+                                </p:cTn>
+                              </p:par>
+                            </p:childTnLst>
+                          </p:cTn>
+                        </p:par>
+                      </p:childTnLst>
+                    </p:cTn>
+                  </p:par>
+                </p:childTnLst>
+              </p:cTn>
+              <p:prevCondLst>
+                <p:cond evt="onPrev" delay="0">
+                  <p:tgtEl>
+                    <p:sldTgt/>
+                  </p:tgtEl>
+                </p:cond>
+              </p:prevCondLst>
+              <p:nextCondLst>
+                <p:cond evt="onNext" delay="0">
+                  <p:tgtEl>
+                    <p:sldTgt/>
+                  </p:tgtEl>
+                </p:cond>
+              </p:nextCondLst>
+            </p:seq>
+          </p:childTnLst>
+        </p:cTn>
+      </p:par>
+    </p:tnLst>
+    <p:bldLst>
+      <p:bldP spid="2" grpId="0"/>
+    </p:bldLst>
+  </p:timing>
 </p:sld>
 </file>
 

</xml_diff>